<commit_message>
Setting default time zone and fixing the product currency icons
</commit_message>
<xml_diff>
--- a/.lessons/63 General settings/3 Setting default time zone and fixing the product currency icons/1.pptx
+++ b/.lessons/63 General settings/3 Setting default time zone and fixing the product currency icons/1.pptx
@@ -6,10 +6,18 @@
   </p:sldMasterIdLst>
   <p:sldIdLst>
     <p:sldId id="415" r:id="rId2"/>
-    <p:sldId id="416" r:id="rId3"/>
-    <p:sldId id="417" r:id="rId4"/>
-    <p:sldId id="418" r:id="rId5"/>
-    <p:sldId id="419" r:id="rId6"/>
+    <p:sldId id="420" r:id="rId3"/>
+    <p:sldId id="421" r:id="rId4"/>
+    <p:sldId id="424" r:id="rId5"/>
+    <p:sldId id="425" r:id="rId6"/>
+    <p:sldId id="416" r:id="rId7"/>
+    <p:sldId id="417" r:id="rId8"/>
+    <p:sldId id="418" r:id="rId9"/>
+    <p:sldId id="422" r:id="rId10"/>
+    <p:sldId id="419" r:id="rId11"/>
+    <p:sldId id="426" r:id="rId12"/>
+    <p:sldId id="427" r:id="rId13"/>
+    <p:sldId id="428" r:id="rId14"/>
   </p:sldIdLst>
   <p:sldSz cx="12192000" cy="6858000"/>
   <p:notesSz cx="6858000" cy="9144000"/>
@@ -263,7 +271,7 @@
           <a:p>
             <a:fld id="{3E102D2E-813C-461C-9963-687A650C48C0}" type="datetimeFigureOut">
               <a:rPr lang="en-US" smtClean="0"/>
-              <a:t>12/24/2025</a:t>
+              <a:t>12/29/2025</a:t>
             </a:fld>
             <a:endParaRPr lang="en-US"/>
           </a:p>
@@ -461,7 +469,7 @@
           <a:p>
             <a:fld id="{3E102D2E-813C-461C-9963-687A650C48C0}" type="datetimeFigureOut">
               <a:rPr lang="en-US" smtClean="0"/>
-              <a:t>12/24/2025</a:t>
+              <a:t>12/29/2025</a:t>
             </a:fld>
             <a:endParaRPr lang="en-US"/>
           </a:p>
@@ -669,7 +677,7 @@
           <a:p>
             <a:fld id="{3E102D2E-813C-461C-9963-687A650C48C0}" type="datetimeFigureOut">
               <a:rPr lang="en-US" smtClean="0"/>
-              <a:t>12/24/2025</a:t>
+              <a:t>12/29/2025</a:t>
             </a:fld>
             <a:endParaRPr lang="en-US"/>
           </a:p>
@@ -867,7 +875,7 @@
           <a:p>
             <a:fld id="{3E102D2E-813C-461C-9963-687A650C48C0}" type="datetimeFigureOut">
               <a:rPr lang="en-US" smtClean="0"/>
-              <a:t>12/24/2025</a:t>
+              <a:t>12/29/2025</a:t>
             </a:fld>
             <a:endParaRPr lang="en-US"/>
           </a:p>
@@ -1142,7 +1150,7 @@
           <a:p>
             <a:fld id="{3E102D2E-813C-461C-9963-687A650C48C0}" type="datetimeFigureOut">
               <a:rPr lang="en-US" smtClean="0"/>
-              <a:t>12/24/2025</a:t>
+              <a:t>12/29/2025</a:t>
             </a:fld>
             <a:endParaRPr lang="en-US"/>
           </a:p>
@@ -1407,7 +1415,7 @@
           <a:p>
             <a:fld id="{3E102D2E-813C-461C-9963-687A650C48C0}" type="datetimeFigureOut">
               <a:rPr lang="en-US" smtClean="0"/>
-              <a:t>12/24/2025</a:t>
+              <a:t>12/29/2025</a:t>
             </a:fld>
             <a:endParaRPr lang="en-US"/>
           </a:p>
@@ -1819,7 +1827,7 @@
           <a:p>
             <a:fld id="{3E102D2E-813C-461C-9963-687A650C48C0}" type="datetimeFigureOut">
               <a:rPr lang="en-US" smtClean="0"/>
-              <a:t>12/24/2025</a:t>
+              <a:t>12/29/2025</a:t>
             </a:fld>
             <a:endParaRPr lang="en-US"/>
           </a:p>
@@ -1960,7 +1968,7 @@
           <a:p>
             <a:fld id="{3E102D2E-813C-461C-9963-687A650C48C0}" type="datetimeFigureOut">
               <a:rPr lang="en-US" smtClean="0"/>
-              <a:t>12/24/2025</a:t>
+              <a:t>12/29/2025</a:t>
             </a:fld>
             <a:endParaRPr lang="en-US"/>
           </a:p>
@@ -2073,7 +2081,7 @@
           <a:p>
             <a:fld id="{3E102D2E-813C-461C-9963-687A650C48C0}" type="datetimeFigureOut">
               <a:rPr lang="en-US" smtClean="0"/>
-              <a:t>12/24/2025</a:t>
+              <a:t>12/29/2025</a:t>
             </a:fld>
             <a:endParaRPr lang="en-US"/>
           </a:p>
@@ -2384,7 +2392,7 @@
           <a:p>
             <a:fld id="{3E102D2E-813C-461C-9963-687A650C48C0}" type="datetimeFigureOut">
               <a:rPr lang="en-US" smtClean="0"/>
-              <a:t>12/24/2025</a:t>
+              <a:t>12/29/2025</a:t>
             </a:fld>
             <a:endParaRPr lang="en-US"/>
           </a:p>
@@ -2672,7 +2680,7 @@
           <a:p>
             <a:fld id="{3E102D2E-813C-461C-9963-687A650C48C0}" type="datetimeFigureOut">
               <a:rPr lang="en-US" smtClean="0"/>
-              <a:t>12/24/2025</a:t>
+              <a:t>12/29/2025</a:t>
             </a:fld>
             <a:endParaRPr lang="en-US"/>
           </a:p>
@@ -2913,7 +2921,7 @@
           <a:p>
             <a:fld id="{3E102D2E-813C-461C-9963-687A650C48C0}" type="datetimeFigureOut">
               <a:rPr lang="en-US" smtClean="0"/>
-              <a:t>12/24/2025</a:t>
+              <a:t>12/29/2025</a:t>
             </a:fld>
             <a:endParaRPr lang="en-US"/>
           </a:p>
@@ -3386,6 +3394,36 @@
           </a:p>
         </p:txBody>
       </p:sp>
+      <p:pic>
+        <p:nvPicPr>
+          <p:cNvPr id="4" name="Picture 3">
+            <a:extLst>
+              <a:ext uri="{FF2B5EF4-FFF2-40B4-BE49-F238E27FC236}">
+                <a16:creationId xmlns:a16="http://schemas.microsoft.com/office/drawing/2014/main" id="{2C68A6FE-3097-B656-0BC4-19D7619C7263}"/>
+              </a:ext>
+            </a:extLst>
+          </p:cNvPr>
+          <p:cNvPicPr>
+            <a:picLocks noChangeAspect="1"/>
+          </p:cNvPicPr>
+          <p:nvPr/>
+        </p:nvPicPr>
+        <p:blipFill>
+          <a:blip r:embed="rId2"/>
+          <a:stretch>
+            <a:fillRect/>
+          </a:stretch>
+        </p:blipFill>
+        <p:spPr>
+          <a:xfrm>
+            <a:off x="2323742" y="0"/>
+            <a:ext cx="7544515" cy="6858000"/>
+          </a:xfrm>
+          <a:prstGeom prst="rect">
+            <a:avLst/>
+          </a:prstGeom>
+        </p:spPr>
+      </p:pic>
     </p:spTree>
     <p:extLst>
       <p:ext uri="{BB962C8B-B14F-4D97-AF65-F5344CB8AC3E}">
@@ -3399,7 +3437,935 @@
 </p:sld>
 </file>
 
+<file path=ppt/slides/slide10.xml><?xml version="1.0" encoding="utf-8"?>
+<p:sld xmlns:a="http://schemas.openxmlformats.org/drawingml/2006/main" xmlns:r="http://schemas.openxmlformats.org/officeDocument/2006/relationships" xmlns:p="http://schemas.openxmlformats.org/presentationml/2006/main">
+  <p:cSld>
+    <p:spTree>
+      <p:nvGrpSpPr>
+        <p:cNvPr id="1" name="">
+          <a:extLst>
+            <a:ext uri="{FF2B5EF4-FFF2-40B4-BE49-F238E27FC236}">
+              <a16:creationId xmlns:a16="http://schemas.microsoft.com/office/drawing/2014/main" id="{234FC578-E916-157D-9E34-98C92603E544}"/>
+            </a:ext>
+          </a:extLst>
+        </p:cNvPr>
+        <p:cNvGrpSpPr/>
+        <p:nvPr/>
+      </p:nvGrpSpPr>
+      <p:grpSpPr>
+        <a:xfrm>
+          <a:off x="0" y="0"/>
+          <a:ext cx="0" cy="0"/>
+          <a:chOff x="0" y="0"/>
+          <a:chExt cx="0" cy="0"/>
+        </a:xfrm>
+      </p:grpSpPr>
+      <p:sp>
+        <p:nvSpPr>
+          <p:cNvPr id="3" name="TextBox 2">
+            <a:extLst>
+              <a:ext uri="{FF2B5EF4-FFF2-40B4-BE49-F238E27FC236}">
+                <a16:creationId xmlns:a16="http://schemas.microsoft.com/office/drawing/2014/main" id="{44E910EB-F8CF-72DB-1654-E9E111A3D87E}"/>
+              </a:ext>
+            </a:extLst>
+          </p:cNvPr>
+          <p:cNvSpPr txBox="1"/>
+          <p:nvPr/>
+        </p:nvSpPr>
+        <p:spPr>
+          <a:xfrm>
+            <a:off x="0" y="0"/>
+            <a:ext cx="12192000" cy="355354"/>
+          </a:xfrm>
+          <a:prstGeom prst="rect">
+            <a:avLst/>
+          </a:prstGeom>
+          <a:noFill/>
+        </p:spPr>
+        <p:txBody>
+          <a:bodyPr wrap="square">
+            <a:spAutoFit/>
+          </a:bodyPr>
+          <a:lstStyle/>
+          <a:p>
+            <a:pPr>
+              <a:lnSpc>
+                <a:spcPct val="150000"/>
+              </a:lnSpc>
+              <a:buNone/>
+            </a:pPr>
+            <a:r>
+              <a:rPr kumimoji="0" lang="en-US" altLang="en-US" sz="1300" b="0" i="0" u="none" strike="noStrike" cap="none" normalizeH="0" baseline="0">
+                <a:ln>
+                  <a:noFill/>
+                </a:ln>
+                <a:solidFill>
+                  <a:schemeClr val="tx1"/>
+                </a:solidFill>
+                <a:effectLst/>
+                <a:latin typeface="Arial" panose="020B0604020202020204" pitchFamily="34" charset="0"/>
+              </a:rPr>
+              <a:t>.</a:t>
+            </a:r>
+          </a:p>
+        </p:txBody>
+      </p:sp>
+      <p:pic>
+        <p:nvPicPr>
+          <p:cNvPr id="4" name="Picture 3">
+            <a:extLst>
+              <a:ext uri="{FF2B5EF4-FFF2-40B4-BE49-F238E27FC236}">
+                <a16:creationId xmlns:a16="http://schemas.microsoft.com/office/drawing/2014/main" id="{BE154C86-7E06-A582-B751-C808D5C3AB76}"/>
+              </a:ext>
+            </a:extLst>
+          </p:cNvPr>
+          <p:cNvPicPr>
+            <a:picLocks noChangeAspect="1"/>
+          </p:cNvPicPr>
+          <p:nvPr/>
+        </p:nvPicPr>
+        <p:blipFill>
+          <a:blip r:embed="rId2"/>
+          <a:stretch>
+            <a:fillRect/>
+          </a:stretch>
+        </p:blipFill>
+        <p:spPr>
+          <a:xfrm>
+            <a:off x="1177060" y="0"/>
+            <a:ext cx="9837880" cy="6858000"/>
+          </a:xfrm>
+          <a:prstGeom prst="rect">
+            <a:avLst/>
+          </a:prstGeom>
+        </p:spPr>
+      </p:pic>
+    </p:spTree>
+    <p:extLst>
+      <p:ext uri="{BB962C8B-B14F-4D97-AF65-F5344CB8AC3E}">
+        <p14:creationId xmlns:p14="http://schemas.microsoft.com/office/powerpoint/2010/main" val="616314994"/>
+      </p:ext>
+    </p:extLst>
+  </p:cSld>
+  <p:clrMapOvr>
+    <a:masterClrMapping/>
+  </p:clrMapOvr>
+</p:sld>
+</file>
+
+<file path=ppt/slides/slide11.xml><?xml version="1.0" encoding="utf-8"?>
+<p:sld xmlns:a="http://schemas.openxmlformats.org/drawingml/2006/main" xmlns:r="http://schemas.openxmlformats.org/officeDocument/2006/relationships" xmlns:p="http://schemas.openxmlformats.org/presentationml/2006/main">
+  <p:cSld>
+    <p:spTree>
+      <p:nvGrpSpPr>
+        <p:cNvPr id="1" name="">
+          <a:extLst>
+            <a:ext uri="{FF2B5EF4-FFF2-40B4-BE49-F238E27FC236}">
+              <a16:creationId xmlns:a16="http://schemas.microsoft.com/office/drawing/2014/main" id="{363199A8-C6DC-BF5A-65F2-F1A8BCC29404}"/>
+            </a:ext>
+          </a:extLst>
+        </p:cNvPr>
+        <p:cNvGrpSpPr/>
+        <p:nvPr/>
+      </p:nvGrpSpPr>
+      <p:grpSpPr>
+        <a:xfrm>
+          <a:off x="0" y="0"/>
+          <a:ext cx="0" cy="0"/>
+          <a:chOff x="0" y="0"/>
+          <a:chExt cx="0" cy="0"/>
+        </a:xfrm>
+      </p:grpSpPr>
+      <p:sp>
+        <p:nvSpPr>
+          <p:cNvPr id="3" name="TextBox 2">
+            <a:extLst>
+              <a:ext uri="{FF2B5EF4-FFF2-40B4-BE49-F238E27FC236}">
+                <a16:creationId xmlns:a16="http://schemas.microsoft.com/office/drawing/2014/main" id="{D15490A9-A048-8810-F95A-5225286F8A93}"/>
+              </a:ext>
+            </a:extLst>
+          </p:cNvPr>
+          <p:cNvSpPr txBox="1"/>
+          <p:nvPr/>
+        </p:nvSpPr>
+        <p:spPr>
+          <a:xfrm>
+            <a:off x="0" y="0"/>
+            <a:ext cx="12192000" cy="355354"/>
+          </a:xfrm>
+          <a:prstGeom prst="rect">
+            <a:avLst/>
+          </a:prstGeom>
+          <a:noFill/>
+        </p:spPr>
+        <p:txBody>
+          <a:bodyPr wrap="square">
+            <a:spAutoFit/>
+          </a:bodyPr>
+          <a:lstStyle/>
+          <a:p>
+            <a:pPr>
+              <a:lnSpc>
+                <a:spcPct val="150000"/>
+              </a:lnSpc>
+              <a:buNone/>
+            </a:pPr>
+            <a:r>
+              <a:rPr kumimoji="0" lang="en-US" altLang="en-US" sz="1300" b="0" i="0" u="none" strike="noStrike" cap="none" normalizeH="0" baseline="0">
+                <a:ln>
+                  <a:noFill/>
+                </a:ln>
+                <a:solidFill>
+                  <a:schemeClr val="tx1"/>
+                </a:solidFill>
+                <a:effectLst/>
+                <a:latin typeface="Arial" panose="020B0604020202020204" pitchFamily="34" charset="0"/>
+              </a:rPr>
+              <a:t>.</a:t>
+            </a:r>
+          </a:p>
+        </p:txBody>
+      </p:sp>
+      <p:pic>
+        <p:nvPicPr>
+          <p:cNvPr id="5" name="Picture 4">
+            <a:extLst>
+              <a:ext uri="{FF2B5EF4-FFF2-40B4-BE49-F238E27FC236}">
+                <a16:creationId xmlns:a16="http://schemas.microsoft.com/office/drawing/2014/main" id="{3712C104-CBC7-5799-C045-29B825230830}"/>
+              </a:ext>
+            </a:extLst>
+          </p:cNvPr>
+          <p:cNvPicPr>
+            <a:picLocks noChangeAspect="1"/>
+          </p:cNvPicPr>
+          <p:nvPr/>
+        </p:nvPicPr>
+        <p:blipFill>
+          <a:blip r:embed="rId2"/>
+          <a:stretch>
+            <a:fillRect/>
+          </a:stretch>
+        </p:blipFill>
+        <p:spPr>
+          <a:xfrm>
+            <a:off x="0" y="420791"/>
+            <a:ext cx="12192000" cy="6016417"/>
+          </a:xfrm>
+          <a:prstGeom prst="rect">
+            <a:avLst/>
+          </a:prstGeom>
+          <a:solidFill>
+            <a:srgbClr val="FFFFFF">
+              <a:shade val="85000"/>
+            </a:srgbClr>
+          </a:solidFill>
+          <a:ln w="88900" cap="sq">
+            <a:solidFill>
+              <a:srgbClr val="FFFFFF"/>
+            </a:solidFill>
+            <a:miter lim="800000"/>
+          </a:ln>
+          <a:effectLst>
+            <a:outerShdw blurRad="55000" dist="18000" dir="5400000" algn="tl" rotWithShape="0">
+              <a:srgbClr val="000000">
+                <a:alpha val="40000"/>
+              </a:srgbClr>
+            </a:outerShdw>
+          </a:effectLst>
+          <a:scene3d>
+            <a:camera prst="orthographicFront"/>
+            <a:lightRig rig="twoPt" dir="t">
+              <a:rot lat="0" lon="0" rev="7200000"/>
+            </a:lightRig>
+          </a:scene3d>
+          <a:sp3d>
+            <a:bevelT w="25400" h="19050"/>
+            <a:contourClr>
+              <a:srgbClr val="FFFFFF"/>
+            </a:contourClr>
+          </a:sp3d>
+        </p:spPr>
+      </p:pic>
+    </p:spTree>
+    <p:extLst>
+      <p:ext uri="{BB962C8B-B14F-4D97-AF65-F5344CB8AC3E}">
+        <p14:creationId xmlns:p14="http://schemas.microsoft.com/office/powerpoint/2010/main" val="1664447852"/>
+      </p:ext>
+    </p:extLst>
+  </p:cSld>
+  <p:clrMapOvr>
+    <a:masterClrMapping/>
+  </p:clrMapOvr>
+</p:sld>
+</file>
+
+<file path=ppt/slides/slide12.xml><?xml version="1.0" encoding="utf-8"?>
+<p:sld xmlns:a="http://schemas.openxmlformats.org/drawingml/2006/main" xmlns:r="http://schemas.openxmlformats.org/officeDocument/2006/relationships" xmlns:p="http://schemas.openxmlformats.org/presentationml/2006/main">
+  <p:cSld>
+    <p:spTree>
+      <p:nvGrpSpPr>
+        <p:cNvPr id="1" name="">
+          <a:extLst>
+            <a:ext uri="{FF2B5EF4-FFF2-40B4-BE49-F238E27FC236}">
+              <a16:creationId xmlns:a16="http://schemas.microsoft.com/office/drawing/2014/main" id="{E66FEF88-5698-8F9C-47A6-527B975391CB}"/>
+            </a:ext>
+          </a:extLst>
+        </p:cNvPr>
+        <p:cNvGrpSpPr/>
+        <p:nvPr/>
+      </p:nvGrpSpPr>
+      <p:grpSpPr>
+        <a:xfrm>
+          <a:off x="0" y="0"/>
+          <a:ext cx="0" cy="0"/>
+          <a:chOff x="0" y="0"/>
+          <a:chExt cx="0" cy="0"/>
+        </a:xfrm>
+      </p:grpSpPr>
+      <p:sp>
+        <p:nvSpPr>
+          <p:cNvPr id="3" name="TextBox 2">
+            <a:extLst>
+              <a:ext uri="{FF2B5EF4-FFF2-40B4-BE49-F238E27FC236}">
+                <a16:creationId xmlns:a16="http://schemas.microsoft.com/office/drawing/2014/main" id="{7E990D5D-6CEB-2474-9547-ECDE45E4E643}"/>
+              </a:ext>
+            </a:extLst>
+          </p:cNvPr>
+          <p:cNvSpPr txBox="1"/>
+          <p:nvPr/>
+        </p:nvSpPr>
+        <p:spPr>
+          <a:xfrm>
+            <a:off x="0" y="0"/>
+            <a:ext cx="12192000" cy="355354"/>
+          </a:xfrm>
+          <a:prstGeom prst="rect">
+            <a:avLst/>
+          </a:prstGeom>
+          <a:noFill/>
+        </p:spPr>
+        <p:txBody>
+          <a:bodyPr wrap="square">
+            <a:spAutoFit/>
+          </a:bodyPr>
+          <a:lstStyle/>
+          <a:p>
+            <a:pPr>
+              <a:lnSpc>
+                <a:spcPct val="150000"/>
+              </a:lnSpc>
+              <a:buNone/>
+            </a:pPr>
+            <a:r>
+              <a:rPr kumimoji="0" lang="en-US" altLang="en-US" sz="1300" b="0" i="0" u="none" strike="noStrike" cap="none" normalizeH="0" baseline="0">
+                <a:ln>
+                  <a:noFill/>
+                </a:ln>
+                <a:solidFill>
+                  <a:schemeClr val="tx1"/>
+                </a:solidFill>
+                <a:effectLst/>
+                <a:latin typeface="Arial" panose="020B0604020202020204" pitchFamily="34" charset="0"/>
+              </a:rPr>
+              <a:t>.</a:t>
+            </a:r>
+          </a:p>
+        </p:txBody>
+      </p:sp>
+    </p:spTree>
+    <p:extLst>
+      <p:ext uri="{BB962C8B-B14F-4D97-AF65-F5344CB8AC3E}">
+        <p14:creationId xmlns:p14="http://schemas.microsoft.com/office/powerpoint/2010/main" val="1294525099"/>
+      </p:ext>
+    </p:extLst>
+  </p:cSld>
+  <p:clrMapOvr>
+    <a:masterClrMapping/>
+  </p:clrMapOvr>
+</p:sld>
+</file>
+
+<file path=ppt/slides/slide13.xml><?xml version="1.0" encoding="utf-8"?>
+<p:sld xmlns:a="http://schemas.openxmlformats.org/drawingml/2006/main" xmlns:r="http://schemas.openxmlformats.org/officeDocument/2006/relationships" xmlns:p="http://schemas.openxmlformats.org/presentationml/2006/main">
+  <p:cSld>
+    <p:spTree>
+      <p:nvGrpSpPr>
+        <p:cNvPr id="1" name="">
+          <a:extLst>
+            <a:ext uri="{FF2B5EF4-FFF2-40B4-BE49-F238E27FC236}">
+              <a16:creationId xmlns:a16="http://schemas.microsoft.com/office/drawing/2014/main" id="{E8E29587-DF46-A3D0-EEA5-A517BEC5B904}"/>
+            </a:ext>
+          </a:extLst>
+        </p:cNvPr>
+        <p:cNvGrpSpPr/>
+        <p:nvPr/>
+      </p:nvGrpSpPr>
+      <p:grpSpPr>
+        <a:xfrm>
+          <a:off x="0" y="0"/>
+          <a:ext cx="0" cy="0"/>
+          <a:chOff x="0" y="0"/>
+          <a:chExt cx="0" cy="0"/>
+        </a:xfrm>
+      </p:grpSpPr>
+      <p:sp>
+        <p:nvSpPr>
+          <p:cNvPr id="3" name="TextBox 2">
+            <a:extLst>
+              <a:ext uri="{FF2B5EF4-FFF2-40B4-BE49-F238E27FC236}">
+                <a16:creationId xmlns:a16="http://schemas.microsoft.com/office/drawing/2014/main" id="{8470951E-E276-20D2-8584-7D31EE3FDC14}"/>
+              </a:ext>
+            </a:extLst>
+          </p:cNvPr>
+          <p:cNvSpPr txBox="1"/>
+          <p:nvPr/>
+        </p:nvSpPr>
+        <p:spPr>
+          <a:xfrm>
+            <a:off x="0" y="0"/>
+            <a:ext cx="12192000" cy="355354"/>
+          </a:xfrm>
+          <a:prstGeom prst="rect">
+            <a:avLst/>
+          </a:prstGeom>
+          <a:noFill/>
+        </p:spPr>
+        <p:txBody>
+          <a:bodyPr wrap="square">
+            <a:spAutoFit/>
+          </a:bodyPr>
+          <a:lstStyle/>
+          <a:p>
+            <a:pPr>
+              <a:lnSpc>
+                <a:spcPct val="150000"/>
+              </a:lnSpc>
+              <a:buNone/>
+            </a:pPr>
+            <a:r>
+              <a:rPr kumimoji="0" lang="en-US" altLang="en-US" sz="1300" b="0" i="0" u="none" strike="noStrike" cap="none" normalizeH="0" baseline="0">
+                <a:ln>
+                  <a:noFill/>
+                </a:ln>
+                <a:solidFill>
+                  <a:schemeClr val="tx1"/>
+                </a:solidFill>
+                <a:effectLst/>
+                <a:latin typeface="Arial" panose="020B0604020202020204" pitchFamily="34" charset="0"/>
+              </a:rPr>
+              <a:t>.</a:t>
+            </a:r>
+          </a:p>
+        </p:txBody>
+      </p:sp>
+    </p:spTree>
+    <p:extLst>
+      <p:ext uri="{BB962C8B-B14F-4D97-AF65-F5344CB8AC3E}">
+        <p14:creationId xmlns:p14="http://schemas.microsoft.com/office/powerpoint/2010/main" val="2287672809"/>
+      </p:ext>
+    </p:extLst>
+  </p:cSld>
+  <p:clrMapOvr>
+    <a:masterClrMapping/>
+  </p:clrMapOvr>
+</p:sld>
+</file>
+
 <file path=ppt/slides/slide2.xml><?xml version="1.0" encoding="utf-8"?>
+<p:sld xmlns:a="http://schemas.openxmlformats.org/drawingml/2006/main" xmlns:r="http://schemas.openxmlformats.org/officeDocument/2006/relationships" xmlns:p="http://schemas.openxmlformats.org/presentationml/2006/main">
+  <p:cSld>
+    <p:spTree>
+      <p:nvGrpSpPr>
+        <p:cNvPr id="1" name="">
+          <a:extLst>
+            <a:ext uri="{FF2B5EF4-FFF2-40B4-BE49-F238E27FC236}">
+              <a16:creationId xmlns:a16="http://schemas.microsoft.com/office/drawing/2014/main" id="{130DCB16-518F-523B-DC5A-C8394B68F808}"/>
+            </a:ext>
+          </a:extLst>
+        </p:cNvPr>
+        <p:cNvGrpSpPr/>
+        <p:nvPr/>
+      </p:nvGrpSpPr>
+      <p:grpSpPr>
+        <a:xfrm>
+          <a:off x="0" y="0"/>
+          <a:ext cx="0" cy="0"/>
+          <a:chOff x="0" y="0"/>
+          <a:chExt cx="0" cy="0"/>
+        </a:xfrm>
+      </p:grpSpPr>
+      <p:sp>
+        <p:nvSpPr>
+          <p:cNvPr id="3" name="TextBox 2">
+            <a:extLst>
+              <a:ext uri="{FF2B5EF4-FFF2-40B4-BE49-F238E27FC236}">
+                <a16:creationId xmlns:a16="http://schemas.microsoft.com/office/drawing/2014/main" id="{D17620C1-7FC8-C763-7FC4-2A5801397EAC}"/>
+              </a:ext>
+            </a:extLst>
+          </p:cNvPr>
+          <p:cNvSpPr txBox="1"/>
+          <p:nvPr/>
+        </p:nvSpPr>
+        <p:spPr>
+          <a:xfrm>
+            <a:off x="0" y="0"/>
+            <a:ext cx="12192000" cy="355354"/>
+          </a:xfrm>
+          <a:prstGeom prst="rect">
+            <a:avLst/>
+          </a:prstGeom>
+          <a:noFill/>
+        </p:spPr>
+        <p:txBody>
+          <a:bodyPr wrap="square">
+            <a:spAutoFit/>
+          </a:bodyPr>
+          <a:lstStyle/>
+          <a:p>
+            <a:pPr>
+              <a:lnSpc>
+                <a:spcPct val="150000"/>
+              </a:lnSpc>
+              <a:buNone/>
+            </a:pPr>
+            <a:r>
+              <a:rPr kumimoji="0" lang="en-US" altLang="en-US" sz="1300" b="0" i="0" u="none" strike="noStrike" cap="none" normalizeH="0" baseline="0">
+                <a:ln>
+                  <a:noFill/>
+                </a:ln>
+                <a:solidFill>
+                  <a:schemeClr val="tx1"/>
+                </a:solidFill>
+                <a:effectLst/>
+                <a:latin typeface="Arial" panose="020B0604020202020204" pitchFamily="34" charset="0"/>
+              </a:rPr>
+              <a:t>.</a:t>
+            </a:r>
+          </a:p>
+        </p:txBody>
+      </p:sp>
+      <p:pic>
+        <p:nvPicPr>
+          <p:cNvPr id="4" name="Picture 3">
+            <a:extLst>
+              <a:ext uri="{FF2B5EF4-FFF2-40B4-BE49-F238E27FC236}">
+                <a16:creationId xmlns:a16="http://schemas.microsoft.com/office/drawing/2014/main" id="{581FE6B0-4EF2-B6DD-3D69-44A5BC580815}"/>
+              </a:ext>
+            </a:extLst>
+          </p:cNvPr>
+          <p:cNvPicPr>
+            <a:picLocks noChangeAspect="1"/>
+          </p:cNvPicPr>
+          <p:nvPr/>
+        </p:nvPicPr>
+        <p:blipFill>
+          <a:blip r:embed="rId2"/>
+          <a:stretch>
+            <a:fillRect/>
+          </a:stretch>
+        </p:blipFill>
+        <p:spPr>
+          <a:xfrm>
+            <a:off x="1679592" y="0"/>
+            <a:ext cx="8832816" cy="6858000"/>
+          </a:xfrm>
+          <a:prstGeom prst="rect">
+            <a:avLst/>
+          </a:prstGeom>
+        </p:spPr>
+      </p:pic>
+    </p:spTree>
+    <p:extLst>
+      <p:ext uri="{BB962C8B-B14F-4D97-AF65-F5344CB8AC3E}">
+        <p14:creationId xmlns:p14="http://schemas.microsoft.com/office/powerpoint/2010/main" val="3265312625"/>
+      </p:ext>
+    </p:extLst>
+  </p:cSld>
+  <p:clrMapOvr>
+    <a:masterClrMapping/>
+  </p:clrMapOvr>
+</p:sld>
+</file>
+
+<file path=ppt/slides/slide3.xml><?xml version="1.0" encoding="utf-8"?>
+<p:sld xmlns:a="http://schemas.openxmlformats.org/drawingml/2006/main" xmlns:r="http://schemas.openxmlformats.org/officeDocument/2006/relationships" xmlns:p="http://schemas.openxmlformats.org/presentationml/2006/main">
+  <p:cSld>
+    <p:spTree>
+      <p:nvGrpSpPr>
+        <p:cNvPr id="1" name="">
+          <a:extLst>
+            <a:ext uri="{FF2B5EF4-FFF2-40B4-BE49-F238E27FC236}">
+              <a16:creationId xmlns:a16="http://schemas.microsoft.com/office/drawing/2014/main" id="{A34919FD-A437-C61C-5F0F-31EF11DEF1DA}"/>
+            </a:ext>
+          </a:extLst>
+        </p:cNvPr>
+        <p:cNvGrpSpPr/>
+        <p:nvPr/>
+      </p:nvGrpSpPr>
+      <p:grpSpPr>
+        <a:xfrm>
+          <a:off x="0" y="0"/>
+          <a:ext cx="0" cy="0"/>
+          <a:chOff x="0" y="0"/>
+          <a:chExt cx="0" cy="0"/>
+        </a:xfrm>
+      </p:grpSpPr>
+      <p:sp>
+        <p:nvSpPr>
+          <p:cNvPr id="3" name="TextBox 2">
+            <a:extLst>
+              <a:ext uri="{FF2B5EF4-FFF2-40B4-BE49-F238E27FC236}">
+                <a16:creationId xmlns:a16="http://schemas.microsoft.com/office/drawing/2014/main" id="{CADE9CB8-044D-3120-DAE0-79C30176752B}"/>
+              </a:ext>
+            </a:extLst>
+          </p:cNvPr>
+          <p:cNvSpPr txBox="1"/>
+          <p:nvPr/>
+        </p:nvSpPr>
+        <p:spPr>
+          <a:xfrm>
+            <a:off x="0" y="0"/>
+            <a:ext cx="12192000" cy="355354"/>
+          </a:xfrm>
+          <a:prstGeom prst="rect">
+            <a:avLst/>
+          </a:prstGeom>
+          <a:noFill/>
+        </p:spPr>
+        <p:txBody>
+          <a:bodyPr wrap="square">
+            <a:spAutoFit/>
+          </a:bodyPr>
+          <a:lstStyle/>
+          <a:p>
+            <a:pPr>
+              <a:lnSpc>
+                <a:spcPct val="150000"/>
+              </a:lnSpc>
+              <a:buNone/>
+            </a:pPr>
+            <a:r>
+              <a:rPr kumimoji="0" lang="en-US" altLang="en-US" sz="1300" b="0" i="0" u="none" strike="noStrike" cap="none" normalizeH="0" baseline="0">
+                <a:ln>
+                  <a:noFill/>
+                </a:ln>
+                <a:solidFill>
+                  <a:schemeClr val="tx1"/>
+                </a:solidFill>
+                <a:effectLst/>
+                <a:latin typeface="Arial" panose="020B0604020202020204" pitchFamily="34" charset="0"/>
+              </a:rPr>
+              <a:t>.</a:t>
+            </a:r>
+          </a:p>
+        </p:txBody>
+      </p:sp>
+      <p:pic>
+        <p:nvPicPr>
+          <p:cNvPr id="4" name="Picture 3">
+            <a:extLst>
+              <a:ext uri="{FF2B5EF4-FFF2-40B4-BE49-F238E27FC236}">
+                <a16:creationId xmlns:a16="http://schemas.microsoft.com/office/drawing/2014/main" id="{7ACF7A48-0FFC-EA28-6C60-66F6C4490438}"/>
+              </a:ext>
+            </a:extLst>
+          </p:cNvPr>
+          <p:cNvPicPr>
+            <a:picLocks noChangeAspect="1"/>
+          </p:cNvPicPr>
+          <p:nvPr/>
+        </p:nvPicPr>
+        <p:blipFill>
+          <a:blip r:embed="rId2"/>
+          <a:stretch>
+            <a:fillRect/>
+          </a:stretch>
+        </p:blipFill>
+        <p:spPr>
+          <a:xfrm>
+            <a:off x="857834" y="0"/>
+            <a:ext cx="10476331" cy="6858000"/>
+          </a:xfrm>
+          <a:prstGeom prst="rect">
+            <a:avLst/>
+          </a:prstGeom>
+        </p:spPr>
+      </p:pic>
+    </p:spTree>
+    <p:extLst>
+      <p:ext uri="{BB962C8B-B14F-4D97-AF65-F5344CB8AC3E}">
+        <p14:creationId xmlns:p14="http://schemas.microsoft.com/office/powerpoint/2010/main" val="2178749120"/>
+      </p:ext>
+    </p:extLst>
+  </p:cSld>
+  <p:clrMapOvr>
+    <a:masterClrMapping/>
+  </p:clrMapOvr>
+</p:sld>
+</file>
+
+<file path=ppt/slides/slide4.xml><?xml version="1.0" encoding="utf-8"?>
+<p:sld xmlns:a="http://schemas.openxmlformats.org/drawingml/2006/main" xmlns:r="http://schemas.openxmlformats.org/officeDocument/2006/relationships" xmlns:p="http://schemas.openxmlformats.org/presentationml/2006/main">
+  <p:cSld>
+    <p:spTree>
+      <p:nvGrpSpPr>
+        <p:cNvPr id="1" name="">
+          <a:extLst>
+            <a:ext uri="{FF2B5EF4-FFF2-40B4-BE49-F238E27FC236}">
+              <a16:creationId xmlns:a16="http://schemas.microsoft.com/office/drawing/2014/main" id="{7F083E05-D1D6-8AAA-029D-E3AB2F4F9EC1}"/>
+            </a:ext>
+          </a:extLst>
+        </p:cNvPr>
+        <p:cNvGrpSpPr/>
+        <p:nvPr/>
+      </p:nvGrpSpPr>
+      <p:grpSpPr>
+        <a:xfrm>
+          <a:off x="0" y="0"/>
+          <a:ext cx="0" cy="0"/>
+          <a:chOff x="0" y="0"/>
+          <a:chExt cx="0" cy="0"/>
+        </a:xfrm>
+      </p:grpSpPr>
+      <p:sp>
+        <p:nvSpPr>
+          <p:cNvPr id="3" name="TextBox 2">
+            <a:extLst>
+              <a:ext uri="{FF2B5EF4-FFF2-40B4-BE49-F238E27FC236}">
+                <a16:creationId xmlns:a16="http://schemas.microsoft.com/office/drawing/2014/main" id="{B672BAB2-B525-C417-A027-06E2C450591F}"/>
+              </a:ext>
+            </a:extLst>
+          </p:cNvPr>
+          <p:cNvSpPr txBox="1"/>
+          <p:nvPr/>
+        </p:nvSpPr>
+        <p:spPr>
+          <a:xfrm>
+            <a:off x="0" y="0"/>
+            <a:ext cx="12192000" cy="355354"/>
+          </a:xfrm>
+          <a:prstGeom prst="rect">
+            <a:avLst/>
+          </a:prstGeom>
+          <a:noFill/>
+        </p:spPr>
+        <p:txBody>
+          <a:bodyPr wrap="square">
+            <a:spAutoFit/>
+          </a:bodyPr>
+          <a:lstStyle/>
+          <a:p>
+            <a:pPr>
+              <a:lnSpc>
+                <a:spcPct val="150000"/>
+              </a:lnSpc>
+              <a:buNone/>
+            </a:pPr>
+            <a:r>
+              <a:rPr kumimoji="0" lang="en-US" altLang="en-US" sz="1300" b="0" i="0" u="none" strike="noStrike" cap="none" normalizeH="0" baseline="0">
+                <a:ln>
+                  <a:noFill/>
+                </a:ln>
+                <a:solidFill>
+                  <a:schemeClr val="tx1"/>
+                </a:solidFill>
+                <a:effectLst/>
+                <a:latin typeface="Arial" panose="020B0604020202020204" pitchFamily="34" charset="0"/>
+              </a:rPr>
+              <a:t>.</a:t>
+            </a:r>
+          </a:p>
+        </p:txBody>
+      </p:sp>
+      <p:pic>
+        <p:nvPicPr>
+          <p:cNvPr id="6" name="Picture 5">
+            <a:extLst>
+              <a:ext uri="{FF2B5EF4-FFF2-40B4-BE49-F238E27FC236}">
+                <a16:creationId xmlns:a16="http://schemas.microsoft.com/office/drawing/2014/main" id="{D06A09CE-A5F7-B754-C8AA-D6090F7E0FB0}"/>
+              </a:ext>
+            </a:extLst>
+          </p:cNvPr>
+          <p:cNvPicPr>
+            <a:picLocks noChangeAspect="1"/>
+          </p:cNvPicPr>
+          <p:nvPr/>
+        </p:nvPicPr>
+        <p:blipFill>
+          <a:blip r:embed="rId2"/>
+          <a:stretch>
+            <a:fillRect/>
+          </a:stretch>
+        </p:blipFill>
+        <p:spPr>
+          <a:xfrm>
+            <a:off x="351358" y="0"/>
+            <a:ext cx="11489284" cy="6858000"/>
+          </a:xfrm>
+          <a:prstGeom prst="rect">
+            <a:avLst/>
+          </a:prstGeom>
+        </p:spPr>
+      </p:pic>
+    </p:spTree>
+    <p:extLst>
+      <p:ext uri="{BB962C8B-B14F-4D97-AF65-F5344CB8AC3E}">
+        <p14:creationId xmlns:p14="http://schemas.microsoft.com/office/powerpoint/2010/main" val="238294060"/>
+      </p:ext>
+    </p:extLst>
+  </p:cSld>
+  <p:clrMapOvr>
+    <a:masterClrMapping/>
+  </p:clrMapOvr>
+</p:sld>
+</file>
+
+<file path=ppt/slides/slide5.xml><?xml version="1.0" encoding="utf-8"?>
+<p:sld xmlns:a="http://schemas.openxmlformats.org/drawingml/2006/main" xmlns:r="http://schemas.openxmlformats.org/officeDocument/2006/relationships" xmlns:p="http://schemas.openxmlformats.org/presentationml/2006/main">
+  <p:cSld>
+    <p:spTree>
+      <p:nvGrpSpPr>
+        <p:cNvPr id="1" name="">
+          <a:extLst>
+            <a:ext uri="{FF2B5EF4-FFF2-40B4-BE49-F238E27FC236}">
+              <a16:creationId xmlns:a16="http://schemas.microsoft.com/office/drawing/2014/main" id="{F66C5780-0DEC-12F8-985E-0FD29593F2B7}"/>
+            </a:ext>
+          </a:extLst>
+        </p:cNvPr>
+        <p:cNvGrpSpPr/>
+        <p:nvPr/>
+      </p:nvGrpSpPr>
+      <p:grpSpPr>
+        <a:xfrm>
+          <a:off x="0" y="0"/>
+          <a:ext cx="0" cy="0"/>
+          <a:chOff x="0" y="0"/>
+          <a:chExt cx="0" cy="0"/>
+        </a:xfrm>
+      </p:grpSpPr>
+      <p:sp>
+        <p:nvSpPr>
+          <p:cNvPr id="3" name="TextBox 2">
+            <a:extLst>
+              <a:ext uri="{FF2B5EF4-FFF2-40B4-BE49-F238E27FC236}">
+                <a16:creationId xmlns:a16="http://schemas.microsoft.com/office/drawing/2014/main" id="{B4D36673-0E48-A050-6A66-26F625F3207E}"/>
+              </a:ext>
+            </a:extLst>
+          </p:cNvPr>
+          <p:cNvSpPr txBox="1"/>
+          <p:nvPr/>
+        </p:nvSpPr>
+        <p:spPr>
+          <a:xfrm>
+            <a:off x="0" y="0"/>
+            <a:ext cx="12192000" cy="355354"/>
+          </a:xfrm>
+          <a:prstGeom prst="rect">
+            <a:avLst/>
+          </a:prstGeom>
+          <a:noFill/>
+        </p:spPr>
+        <p:txBody>
+          <a:bodyPr wrap="square">
+            <a:spAutoFit/>
+          </a:bodyPr>
+          <a:lstStyle/>
+          <a:p>
+            <a:pPr>
+              <a:lnSpc>
+                <a:spcPct val="150000"/>
+              </a:lnSpc>
+              <a:buNone/>
+            </a:pPr>
+            <a:r>
+              <a:rPr kumimoji="0" lang="en-US" altLang="en-US" sz="1300" b="0" i="0" u="none" strike="noStrike" cap="none" normalizeH="0" baseline="0">
+                <a:ln>
+                  <a:noFill/>
+                </a:ln>
+                <a:solidFill>
+                  <a:schemeClr val="tx1"/>
+                </a:solidFill>
+                <a:effectLst/>
+                <a:latin typeface="Arial" panose="020B0604020202020204" pitchFamily="34" charset="0"/>
+              </a:rPr>
+              <a:t>.</a:t>
+            </a:r>
+          </a:p>
+        </p:txBody>
+      </p:sp>
+      <p:pic>
+        <p:nvPicPr>
+          <p:cNvPr id="4" name="Picture 3">
+            <a:extLst>
+              <a:ext uri="{FF2B5EF4-FFF2-40B4-BE49-F238E27FC236}">
+                <a16:creationId xmlns:a16="http://schemas.microsoft.com/office/drawing/2014/main" id="{965953A3-A8D9-3594-592A-A5BD9B3151FB}"/>
+              </a:ext>
+            </a:extLst>
+          </p:cNvPr>
+          <p:cNvPicPr>
+            <a:picLocks noChangeAspect="1"/>
+          </p:cNvPicPr>
+          <p:nvPr/>
+        </p:nvPicPr>
+        <p:blipFill>
+          <a:blip r:embed="rId2"/>
+          <a:stretch>
+            <a:fillRect/>
+          </a:stretch>
+        </p:blipFill>
+        <p:spPr>
+          <a:xfrm>
+            <a:off x="165058" y="0"/>
+            <a:ext cx="11861883" cy="6858000"/>
+          </a:xfrm>
+          <a:prstGeom prst="rect">
+            <a:avLst/>
+          </a:prstGeom>
+          <a:solidFill>
+            <a:srgbClr val="FFFFFF">
+              <a:shade val="85000"/>
+            </a:srgbClr>
+          </a:solidFill>
+          <a:ln w="88900" cap="sq">
+            <a:solidFill>
+              <a:srgbClr val="FFFFFF"/>
+            </a:solidFill>
+            <a:miter lim="800000"/>
+          </a:ln>
+          <a:effectLst>
+            <a:outerShdw blurRad="55000" dist="18000" dir="5400000" algn="tl" rotWithShape="0">
+              <a:srgbClr val="000000">
+                <a:alpha val="40000"/>
+              </a:srgbClr>
+            </a:outerShdw>
+          </a:effectLst>
+          <a:scene3d>
+            <a:camera prst="orthographicFront"/>
+            <a:lightRig rig="twoPt" dir="t">
+              <a:rot lat="0" lon="0" rev="7200000"/>
+            </a:lightRig>
+          </a:scene3d>
+          <a:sp3d>
+            <a:bevelT w="25400" h="19050"/>
+            <a:contourClr>
+              <a:srgbClr val="FFFFFF"/>
+            </a:contourClr>
+          </a:sp3d>
+        </p:spPr>
+      </p:pic>
+    </p:spTree>
+    <p:extLst>
+      <p:ext uri="{BB962C8B-B14F-4D97-AF65-F5344CB8AC3E}">
+        <p14:creationId xmlns:p14="http://schemas.microsoft.com/office/powerpoint/2010/main" val="1743559454"/>
+      </p:ext>
+    </p:extLst>
+  </p:cSld>
+  <p:clrMapOvr>
+    <a:masterClrMapping/>
+  </p:clrMapOvr>
+</p:sld>
+</file>
+
+<file path=ppt/slides/slide6.xml><?xml version="1.0" encoding="utf-8"?>
 <p:sld xmlns:a="http://schemas.openxmlformats.org/drawingml/2006/main" xmlns:r="http://schemas.openxmlformats.org/officeDocument/2006/relationships" xmlns:p="http://schemas.openxmlformats.org/presentationml/2006/main">
   <p:cSld>
     <p:spTree>
@@ -3472,6 +4438,36 @@
           </a:p>
         </p:txBody>
       </p:sp>
+      <p:pic>
+        <p:nvPicPr>
+          <p:cNvPr id="4" name="Picture 3">
+            <a:extLst>
+              <a:ext uri="{FF2B5EF4-FFF2-40B4-BE49-F238E27FC236}">
+                <a16:creationId xmlns:a16="http://schemas.microsoft.com/office/drawing/2014/main" id="{9751C353-7AC5-D02B-D4FF-06723413FC21}"/>
+              </a:ext>
+            </a:extLst>
+          </p:cNvPr>
+          <p:cNvPicPr>
+            <a:picLocks noChangeAspect="1"/>
+          </p:cNvPicPr>
+          <p:nvPr/>
+        </p:nvPicPr>
+        <p:blipFill>
+          <a:blip r:embed="rId2"/>
+          <a:stretch>
+            <a:fillRect/>
+          </a:stretch>
+        </p:blipFill>
+        <p:spPr>
+          <a:xfrm>
+            <a:off x="504472" y="0"/>
+            <a:ext cx="11183056" cy="6858000"/>
+          </a:xfrm>
+          <a:prstGeom prst="rect">
+            <a:avLst/>
+          </a:prstGeom>
+        </p:spPr>
+      </p:pic>
     </p:spTree>
     <p:extLst>
       <p:ext uri="{BB962C8B-B14F-4D97-AF65-F5344CB8AC3E}">
@@ -3485,7 +4481,7 @@
 </p:sld>
 </file>
 
-<file path=ppt/slides/slide3.xml><?xml version="1.0" encoding="utf-8"?>
+<file path=ppt/slides/slide7.xml><?xml version="1.0" encoding="utf-8"?>
 <p:sld xmlns:a="http://schemas.openxmlformats.org/drawingml/2006/main" xmlns:r="http://schemas.openxmlformats.org/officeDocument/2006/relationships" xmlns:p="http://schemas.openxmlformats.org/presentationml/2006/main">
   <p:cSld>
     <p:spTree>
@@ -3558,6 +4554,36 @@
           </a:p>
         </p:txBody>
       </p:sp>
+      <p:pic>
+        <p:nvPicPr>
+          <p:cNvPr id="4" name="Picture 3">
+            <a:extLst>
+              <a:ext uri="{FF2B5EF4-FFF2-40B4-BE49-F238E27FC236}">
+                <a16:creationId xmlns:a16="http://schemas.microsoft.com/office/drawing/2014/main" id="{A503AB76-4409-DD83-7CA0-86C4A0B2AC45}"/>
+              </a:ext>
+            </a:extLst>
+          </p:cNvPr>
+          <p:cNvPicPr>
+            <a:picLocks noChangeAspect="1"/>
+          </p:cNvPicPr>
+          <p:nvPr/>
+        </p:nvPicPr>
+        <p:blipFill>
+          <a:blip r:embed="rId2"/>
+          <a:stretch>
+            <a:fillRect/>
+          </a:stretch>
+        </p:blipFill>
+        <p:spPr>
+          <a:xfrm>
+            <a:off x="2032796" y="0"/>
+            <a:ext cx="8126408" cy="6858000"/>
+          </a:xfrm>
+          <a:prstGeom prst="rect">
+            <a:avLst/>
+          </a:prstGeom>
+        </p:spPr>
+      </p:pic>
     </p:spTree>
     <p:extLst>
       <p:ext uri="{BB962C8B-B14F-4D97-AF65-F5344CB8AC3E}">
@@ -3571,7 +4597,7 @@
 </p:sld>
 </file>
 
-<file path=ppt/slides/slide4.xml><?xml version="1.0" encoding="utf-8"?>
+<file path=ppt/slides/slide8.xml><?xml version="1.0" encoding="utf-8"?>
 <p:sld xmlns:a="http://schemas.openxmlformats.org/drawingml/2006/main" xmlns:r="http://schemas.openxmlformats.org/officeDocument/2006/relationships" xmlns:p="http://schemas.openxmlformats.org/presentationml/2006/main">
   <p:cSld>
     <p:spTree>
@@ -3644,6 +4670,36 @@
           </a:p>
         </p:txBody>
       </p:sp>
+      <p:pic>
+        <p:nvPicPr>
+          <p:cNvPr id="4" name="Picture 3">
+            <a:extLst>
+              <a:ext uri="{FF2B5EF4-FFF2-40B4-BE49-F238E27FC236}">
+                <a16:creationId xmlns:a16="http://schemas.microsoft.com/office/drawing/2014/main" id="{423B83F4-A945-2984-C2E7-432DD76F30CC}"/>
+              </a:ext>
+            </a:extLst>
+          </p:cNvPr>
+          <p:cNvPicPr>
+            <a:picLocks noChangeAspect="1"/>
+          </p:cNvPicPr>
+          <p:nvPr/>
+        </p:nvPicPr>
+        <p:blipFill>
+          <a:blip r:embed="rId2"/>
+          <a:stretch>
+            <a:fillRect/>
+          </a:stretch>
+        </p:blipFill>
+        <p:spPr>
+          <a:xfrm>
+            <a:off x="1047360" y="0"/>
+            <a:ext cx="10097280" cy="6858000"/>
+          </a:xfrm>
+          <a:prstGeom prst="rect">
+            <a:avLst/>
+          </a:prstGeom>
+        </p:spPr>
+      </p:pic>
     </p:spTree>
     <p:extLst>
       <p:ext uri="{BB962C8B-B14F-4D97-AF65-F5344CB8AC3E}">
@@ -3657,7 +4713,7 @@
 </p:sld>
 </file>
 
-<file path=ppt/slides/slide5.xml><?xml version="1.0" encoding="utf-8"?>
+<file path=ppt/slides/slide9.xml><?xml version="1.0" encoding="utf-8"?>
 <p:sld xmlns:a="http://schemas.openxmlformats.org/drawingml/2006/main" xmlns:r="http://schemas.openxmlformats.org/officeDocument/2006/relationships" xmlns:p="http://schemas.openxmlformats.org/presentationml/2006/main">
   <p:cSld>
     <p:spTree>
@@ -3665,7 +4721,7 @@
         <p:cNvPr id="1" name="">
           <a:extLst>
             <a:ext uri="{FF2B5EF4-FFF2-40B4-BE49-F238E27FC236}">
-              <a16:creationId xmlns:a16="http://schemas.microsoft.com/office/drawing/2014/main" id="{234FC578-E916-157D-9E34-98C92603E544}"/>
+              <a16:creationId xmlns:a16="http://schemas.microsoft.com/office/drawing/2014/main" id="{F1D8C015-6F5B-341C-E2E8-F1E1CF62AA8B}"/>
             </a:ext>
           </a:extLst>
         </p:cNvPr>
@@ -3685,7 +4741,7 @@
           <p:cNvPr id="3" name="TextBox 2">
             <a:extLst>
               <a:ext uri="{FF2B5EF4-FFF2-40B4-BE49-F238E27FC236}">
-                <a16:creationId xmlns:a16="http://schemas.microsoft.com/office/drawing/2014/main" id="{44E910EB-F8CF-72DB-1654-E9E111A3D87E}"/>
+                <a16:creationId xmlns:a16="http://schemas.microsoft.com/office/drawing/2014/main" id="{DECF6621-AB4A-D5A5-52CB-2638C457AE99}"/>
               </a:ext>
             </a:extLst>
           </p:cNvPr>
@@ -3730,10 +4786,40 @@
           </a:p>
         </p:txBody>
       </p:sp>
+      <p:pic>
+        <p:nvPicPr>
+          <p:cNvPr id="4" name="Picture 3">
+            <a:extLst>
+              <a:ext uri="{FF2B5EF4-FFF2-40B4-BE49-F238E27FC236}">
+                <a16:creationId xmlns:a16="http://schemas.microsoft.com/office/drawing/2014/main" id="{2C68FB66-EB43-33D2-8DE0-CABCF6239479}"/>
+              </a:ext>
+            </a:extLst>
+          </p:cNvPr>
+          <p:cNvPicPr>
+            <a:picLocks noChangeAspect="1"/>
+          </p:cNvPicPr>
+          <p:nvPr/>
+        </p:nvPicPr>
+        <p:blipFill>
+          <a:blip r:embed="rId2"/>
+          <a:stretch>
+            <a:fillRect/>
+          </a:stretch>
+        </p:blipFill>
+        <p:spPr>
+          <a:xfrm>
+            <a:off x="671692" y="0"/>
+            <a:ext cx="10848616" cy="6858000"/>
+          </a:xfrm>
+          <a:prstGeom prst="rect">
+            <a:avLst/>
+          </a:prstGeom>
+        </p:spPr>
+      </p:pic>
     </p:spTree>
     <p:extLst>
       <p:ext uri="{BB962C8B-B14F-4D97-AF65-F5344CB8AC3E}">
-        <p14:creationId xmlns:p14="http://schemas.microsoft.com/office/powerpoint/2010/main" val="616314994"/>
+        <p14:creationId xmlns:p14="http://schemas.microsoft.com/office/powerpoint/2010/main" val="2696033208"/>
       </p:ext>
     </p:extLst>
   </p:cSld>

</xml_diff>